<commit_message>
Remove private research repository references
</commit_message>
<xml_diff>
--- a/soutenance-stage/presentation/soutenance-stage-marc-duboc.pptx
+++ b/soutenance-stage/presentation/soutenance-stage-marc-duboc.pptx
@@ -2,34 +2,34 @@
 <file path=ppt/presentation.xml><?xml version="1.0" encoding="utf-8"?>
 <p:presentation xmlns:p="http://schemas.openxmlformats.org/presentationml/2006/main" embedTrueTypeFonts="1" saveSubsetFonts="0">
   <p:sldMasterIdLst>
-    <p:sldMasterId xmlns:r="http://schemas.openxmlformats.org/officeDocument/2006/relationships" id="2147483648" r:id="Raa0f4e22c2d1461e"/>
+    <p:sldMasterId xmlns:r="http://schemas.openxmlformats.org/officeDocument/2006/relationships" id="2147483648" r:id="Rfb56941f17b842b4"/>
   </p:sldMasterIdLst>
   <p:notesMasterIdLst>
-    <p:notesMasterId xmlns:r="http://schemas.openxmlformats.org/officeDocument/2006/relationships" r:id="Re960d5ff5a9f499a"/>
+    <p:notesMasterId xmlns:r="http://schemas.openxmlformats.org/officeDocument/2006/relationships" r:id="Rce0fefc6748c468f"/>
   </p:notesMasterIdLst>
   <p:sldIdLst>
-    <p:sldId xmlns:r="http://schemas.openxmlformats.org/officeDocument/2006/relationships" id="256" r:id="R7b2ad2558e0b4e28"/>
-    <p:sldId xmlns:r="http://schemas.openxmlformats.org/officeDocument/2006/relationships" id="257" r:id="R30c99fb69ccd446f"/>
-    <p:sldId xmlns:r="http://schemas.openxmlformats.org/officeDocument/2006/relationships" id="258" r:id="R1efe04787c144ac9"/>
-    <p:sldId xmlns:r="http://schemas.openxmlformats.org/officeDocument/2006/relationships" id="259" r:id="Rdef6bd744f674f36"/>
-    <p:sldId xmlns:r="http://schemas.openxmlformats.org/officeDocument/2006/relationships" id="260" r:id="R9b8142899b9f497b"/>
+    <p:sldId xmlns:r="http://schemas.openxmlformats.org/officeDocument/2006/relationships" id="256" r:id="R12979293867e4350"/>
+    <p:sldId xmlns:r="http://schemas.openxmlformats.org/officeDocument/2006/relationships" id="257" r:id="Ref1777953542491e"/>
+    <p:sldId xmlns:r="http://schemas.openxmlformats.org/officeDocument/2006/relationships" id="258" r:id="R583c90657cae45d7"/>
+    <p:sldId xmlns:r="http://schemas.openxmlformats.org/officeDocument/2006/relationships" id="259" r:id="Ra5f0b6a93a5c41f7"/>
+    <p:sldId xmlns:r="http://schemas.openxmlformats.org/officeDocument/2006/relationships" id="260" r:id="R8c943adcb8034d11"/>
   </p:sldIdLst>
   <p:sldSz cx="9144000" cy="5143500"/>
   <p:notesSz cx="6858000" cy="9144000"/>
   <p:embeddedFontLst>
     <p:embeddedFont>
       <p:font typeface="Inter SemiBold"/>
-      <p:regular xmlns:r="http://schemas.openxmlformats.org/officeDocument/2006/relationships" r:id="Rf93fbfd8e7554cbe"/>
-      <p:bold xmlns:r="http://schemas.openxmlformats.org/officeDocument/2006/relationships" r:id="Rce1283c6103c4cb0"/>
-      <p:italic xmlns:r="http://schemas.openxmlformats.org/officeDocument/2006/relationships" r:id="Rd6ababcd1df147fc"/>
-      <p:boldItalic xmlns:r="http://schemas.openxmlformats.org/officeDocument/2006/relationships" r:id="Rb19fb077302d48f7"/>
+      <p:regular xmlns:r="http://schemas.openxmlformats.org/officeDocument/2006/relationships" r:id="R815101bd1c7d448c"/>
+      <p:bold xmlns:r="http://schemas.openxmlformats.org/officeDocument/2006/relationships" r:id="R1501f34df91d4ba7"/>
+      <p:italic xmlns:r="http://schemas.openxmlformats.org/officeDocument/2006/relationships" r:id="R9648d3e847f54fbf"/>
+      <p:boldItalic xmlns:r="http://schemas.openxmlformats.org/officeDocument/2006/relationships" r:id="Rbbd7b2dccd404ea0"/>
     </p:embeddedFont>
     <p:embeddedFont>
       <p:font typeface="Inter"/>
-      <p:regular xmlns:r="http://schemas.openxmlformats.org/officeDocument/2006/relationships" r:id="R5adcdda5829d4ca4"/>
-      <p:bold xmlns:r="http://schemas.openxmlformats.org/officeDocument/2006/relationships" r:id="R9b2c9883c94642e3"/>
-      <p:italic xmlns:r="http://schemas.openxmlformats.org/officeDocument/2006/relationships" r:id="R0ebf228c4728460b"/>
-      <p:boldItalic xmlns:r="http://schemas.openxmlformats.org/officeDocument/2006/relationships" r:id="R9e4c643b5d12499a"/>
+      <p:regular xmlns:r="http://schemas.openxmlformats.org/officeDocument/2006/relationships" r:id="Rc5aa02e707d4416d"/>
+      <p:bold xmlns:r="http://schemas.openxmlformats.org/officeDocument/2006/relationships" r:id="R451b2b111c4f4a25"/>
+      <p:italic xmlns:r="http://schemas.openxmlformats.org/officeDocument/2006/relationships" r:id="Ra5766b405f7e471c"/>
+      <p:boldItalic xmlns:r="http://schemas.openxmlformats.org/officeDocument/2006/relationships" r:id="R89e0c83a42514c42"/>
     </p:embeddedFont>
   </p:embeddedFontLst>
 </p:presentation>
@@ -727,7 +727,7 @@
               <a:buNone/>
             </a:pPr>
             <a:r>
-              <a:t>- soutenance-stage/sources/source-traceability.md — périmètre, architecture et frontières de validation.</a:t>
+              <a:t>- docs/evidence/PWS-F1.md et docs/BASELINES.md — chemin PWS, portes de preuve et rollback.</a:t>
             </a:r>
           </a:p>
           <a:p xmlns:a="http://schemas.openxmlformats.org/drawingml/2006/main">
@@ -1053,7 +1053,7 @@
               <a:buNone/>
             </a:pPr>
             <a:r>
-              <a:t>- soutenance-stage/sources/source-traceability.md — 89/100, 52, MCS 5 puis 24–27 et qualification des runs.</a:t>
+              <a:t>- docs/evidence/BENCHMARKS.md et docs/evidence/PWS-F1.md — débits assainis, qualification des essais et service PWS.</a:t>
             </a:r>
           </a:p>
           <a:p xmlns:a="http://schemas.openxmlformats.org/drawingml/2006/main">
@@ -1188,7 +1188,7 @@
               <a:buNone/>
             </a:pPr>
             <a:r>
-              <a:t>- soutenance-stage/sources/source-traceability.md — livrables, limites et prochaines preuves.</a:t>
+              <a:t>- docs/STATUS.md, docs/ARTIFACT_MANIFEST.md et docs/SECURITY.md — livrables, limites et frontière de publication.</a:t>
             </a:r>
           </a:p>
           <a:p xmlns:a="http://schemas.openxmlformats.org/drawingml/2006/main">
@@ -6191,20 +6191,20 @@
   </p:cSld>
   <p:clrMap bg1="lt1" tx1="dk1" bg2="dk2" tx2="lt2" accent1="accent1" accent2="accent2" accent3="accent3" accent4="accent4" accent5="accent5" accent6="accent6" hlink="hlink" folHlink="folHlink"/>
   <p:sldLayoutIdLst>
-    <p:sldLayoutId xmlns:r="http://schemas.openxmlformats.org/officeDocument/2006/relationships" id="2147483649" r:id="Rf426a42363084cc9"/>
-    <p:sldLayoutId xmlns:r="http://schemas.openxmlformats.org/officeDocument/2006/relationships" id="2147483650" r:id="R4494afab4e8a4887"/>
-    <p:sldLayoutId xmlns:r="http://schemas.openxmlformats.org/officeDocument/2006/relationships" id="2147483651" r:id="Rceda9385393a47e9"/>
-    <p:sldLayoutId xmlns:r="http://schemas.openxmlformats.org/officeDocument/2006/relationships" id="2147483652" r:id="Rcfe1e8d6304a418a"/>
-    <p:sldLayoutId xmlns:r="http://schemas.openxmlformats.org/officeDocument/2006/relationships" id="2147483653" r:id="Rb05e81daddd440ba"/>
-    <p:sldLayoutId xmlns:r="http://schemas.openxmlformats.org/officeDocument/2006/relationships" id="2147483654" r:id="R675cd2f778c44628"/>
-    <p:sldLayoutId xmlns:r="http://schemas.openxmlformats.org/officeDocument/2006/relationships" id="2147483655" r:id="R3ee599cf78d14037"/>
-    <p:sldLayoutId xmlns:r="http://schemas.openxmlformats.org/officeDocument/2006/relationships" id="2147483656" r:id="Ra9c4b2b6055f4ffa"/>
-    <p:sldLayoutId xmlns:r="http://schemas.openxmlformats.org/officeDocument/2006/relationships" id="2147483657" r:id="R6dada38dfff149c4"/>
-    <p:sldLayoutId xmlns:r="http://schemas.openxmlformats.org/officeDocument/2006/relationships" id="2147483658" r:id="R45d4f5d7e8324e80"/>
-    <p:sldLayoutId xmlns:r="http://schemas.openxmlformats.org/officeDocument/2006/relationships" id="2147483659" r:id="R05c58883fb7e4d41"/>
-    <p:sldLayoutId xmlns:r="http://schemas.openxmlformats.org/officeDocument/2006/relationships" id="2147483660" r:id="R68c61bf86acf4fa4"/>
-    <p:sldLayoutId xmlns:r="http://schemas.openxmlformats.org/officeDocument/2006/relationships" id="2147483661" r:id="Rcf405c8baad84893"/>
-    <p:sldLayoutId xmlns:r="http://schemas.openxmlformats.org/officeDocument/2006/relationships" id="2147483662" r:id="R8ae4baf2e8b74da4"/>
+    <p:sldLayoutId xmlns:r="http://schemas.openxmlformats.org/officeDocument/2006/relationships" id="2147483649" r:id="R2bb55fec5c7d48e8"/>
+    <p:sldLayoutId xmlns:r="http://schemas.openxmlformats.org/officeDocument/2006/relationships" id="2147483650" r:id="R00ccb3dd4b624c69"/>
+    <p:sldLayoutId xmlns:r="http://schemas.openxmlformats.org/officeDocument/2006/relationships" id="2147483651" r:id="R1e64cd15d0c44913"/>
+    <p:sldLayoutId xmlns:r="http://schemas.openxmlformats.org/officeDocument/2006/relationships" id="2147483652" r:id="R252444ab2ba146db"/>
+    <p:sldLayoutId xmlns:r="http://schemas.openxmlformats.org/officeDocument/2006/relationships" id="2147483653" r:id="Rf720838ac56e4d42"/>
+    <p:sldLayoutId xmlns:r="http://schemas.openxmlformats.org/officeDocument/2006/relationships" id="2147483654" r:id="R40942946c9374a86"/>
+    <p:sldLayoutId xmlns:r="http://schemas.openxmlformats.org/officeDocument/2006/relationships" id="2147483655" r:id="R6864663685ba4510"/>
+    <p:sldLayoutId xmlns:r="http://schemas.openxmlformats.org/officeDocument/2006/relationships" id="2147483656" r:id="R379b78780ad447b1"/>
+    <p:sldLayoutId xmlns:r="http://schemas.openxmlformats.org/officeDocument/2006/relationships" id="2147483657" r:id="R77c39726af074047"/>
+    <p:sldLayoutId xmlns:r="http://schemas.openxmlformats.org/officeDocument/2006/relationships" id="2147483658" r:id="R3cc0958a8bc64d5f"/>
+    <p:sldLayoutId xmlns:r="http://schemas.openxmlformats.org/officeDocument/2006/relationships" id="2147483659" r:id="Rdc4a1c12b7964551"/>
+    <p:sldLayoutId xmlns:r="http://schemas.openxmlformats.org/officeDocument/2006/relationships" id="2147483660" r:id="Rfafbda8a58204af7"/>
+    <p:sldLayoutId xmlns:r="http://schemas.openxmlformats.org/officeDocument/2006/relationships" id="2147483661" r:id="Rc2e73bef429b48c0"/>
+    <p:sldLayoutId xmlns:r="http://schemas.openxmlformats.org/officeDocument/2006/relationships" id="2147483662" r:id="R63b7dcef3d6e4cbd"/>
   </p:sldLayoutIdLst>
   <p:hf sldNum="0" hdr="0" ftr="0" dt="0"/>
   <p:txStyles>
@@ -7525,7 +7525,7 @@
           <p:nvPr/>
         </p:nvPicPr>
         <p:blipFill rotWithShape="1">
-          <a:blip xmlns:r="http://schemas.openxmlformats.org/officeDocument/2006/relationships" xmlns:a="http://schemas.openxmlformats.org/drawingml/2006/main" r:embed="R25d368fd37ba4e8c">
+          <a:blip xmlns:r="http://schemas.openxmlformats.org/officeDocument/2006/relationships" xmlns:a="http://schemas.openxmlformats.org/drawingml/2006/main" r:embed="R95bc1a49afe94b14">
             <a:alphaModFix/>
           </a:blip>
           <a:srcRect xmlns:a="http://schemas.openxmlformats.org/drawingml/2006/main" l="0" t="0" r="0" b="0"/>
@@ -7575,7 +7575,7 @@
           <p:nvPr/>
         </p:nvPicPr>
         <p:blipFill rotWithShape="1">
-          <a:blip xmlns:r="http://schemas.openxmlformats.org/officeDocument/2006/relationships" xmlns:a="http://schemas.openxmlformats.org/drawingml/2006/main" r:embed="Rb0aece19da954b76">
+          <a:blip xmlns:r="http://schemas.openxmlformats.org/officeDocument/2006/relationships" xmlns:a="http://schemas.openxmlformats.org/drawingml/2006/main" r:embed="R3c3fb1b76b63476e">
             <a:alphaModFix/>
           </a:blip>
           <a:srcRect xmlns:a="http://schemas.openxmlformats.org/drawingml/2006/main" l="0" t="5000" r="0" b="8000"/>
@@ -8496,11 +8496,11 @@
           <p:nvPr/>
         </p:nvPicPr>
         <p:blipFill>
-          <a:blip xmlns:r="http://schemas.openxmlformats.org/officeDocument/2006/relationships" xmlns:a="http://schemas.openxmlformats.org/drawingml/2006/main" r:embed="Racce790c329340f2">
+          <a:blip xmlns:r="http://schemas.openxmlformats.org/officeDocument/2006/relationships" xmlns:a="http://schemas.openxmlformats.org/drawingml/2006/main" r:embed="R2ed73fd143f84bdf">
             <a:alphaModFix/>
             <a:extLst>
               <a:ext uri="{96DAC541-7B7A-43D3-8B79-37D633B846F1}">
-                <asvg:svgBlip xmlns:asvg="http://schemas.microsoft.com/office/drawing/2016/SVG/main" r:embed="Rccadf4ac333b4c5b"/>
+                <asvg:svgBlip xmlns:asvg="http://schemas.microsoft.com/office/drawing/2016/SVG/main" r:embed="R7431cac21c4e4d6a"/>
               </a:ext>
             </a:extLst>
           </a:blip>
@@ -8717,11 +8717,11 @@
           <p:nvPr/>
         </p:nvPicPr>
         <p:blipFill rotWithShape="1">
-          <a:blip xmlns:r="http://schemas.openxmlformats.org/officeDocument/2006/relationships" xmlns:a="http://schemas.openxmlformats.org/drawingml/2006/main" r:embed="R52ef51e868264afe">
+          <a:blip xmlns:r="http://schemas.openxmlformats.org/officeDocument/2006/relationships" xmlns:a="http://schemas.openxmlformats.org/drawingml/2006/main" r:embed="R36bad8997f254a65">
             <a:alphaModFix/>
             <a:extLst>
               <a:ext uri="{96DAC541-7B7A-43D3-8B79-37D633B846F1}">
-                <asvg:svgBlip xmlns:asvg="http://schemas.microsoft.com/office/drawing/2016/SVG/main" r:embed="R89698306dca247c5"/>
+                <asvg:svgBlip xmlns:asvg="http://schemas.microsoft.com/office/drawing/2016/SVG/main" r:embed="R8bb4bfe7d59b4f99"/>
               </a:ext>
             </a:extLst>
           </a:blip>
@@ -9005,7 +9005,7 @@
           <p:nvPr/>
         </p:nvPicPr>
         <p:blipFill rotWithShape="1">
-          <a:blip xmlns:r="http://schemas.openxmlformats.org/officeDocument/2006/relationships" xmlns:a="http://schemas.openxmlformats.org/drawingml/2006/main" r:embed="Rcb48cac8121b48e2">
+          <a:blip xmlns:r="http://schemas.openxmlformats.org/officeDocument/2006/relationships" xmlns:a="http://schemas.openxmlformats.org/drawingml/2006/main" r:embed="R872b844490d44fa4">
             <a:alphaModFix/>
           </a:blip>
           <a:srcRect xmlns:a="http://schemas.openxmlformats.org/drawingml/2006/main" l="0" t="16000" r="0" b="37000"/>
@@ -9290,6 +9290,7 @@
           <a:lstStyle xmlns:a="http://schemas.openxmlformats.org/drawingml/2006/main"/>
           <a:p xmlns:a="http://schemas.openxmlformats.org/drawingml/2006/main">
             <a:pPr>
+              <a:buNone/>
               <a:defRPr sz="1350">
                 <a:solidFill>
                   <a:srgbClr val="111827"/>
@@ -9532,6 +9533,7 @@
           <a:lstStyle xmlns:a="http://schemas.openxmlformats.org/drawingml/2006/main"/>
           <a:p xmlns:a="http://schemas.openxmlformats.org/drawingml/2006/main">
             <a:pPr>
+              <a:buNone/>
               <a:defRPr sz="1350">
                 <a:solidFill>
                   <a:srgbClr val="111827"/>
@@ -9774,6 +9776,7 @@
           <a:lstStyle xmlns:a="http://schemas.openxmlformats.org/drawingml/2006/main"/>
           <a:p xmlns:a="http://schemas.openxmlformats.org/drawingml/2006/main">
             <a:pPr>
+              <a:buNone/>
               <a:defRPr sz="1350">
                 <a:solidFill>
                   <a:srgbClr val="111827"/>
@@ -9895,6 +9898,7 @@
           <a:lstStyle xmlns:a="http://schemas.openxmlformats.org/drawingml/2006/main"/>
           <a:p xmlns:a="http://schemas.openxmlformats.org/drawingml/2006/main">
             <a:pPr>
+              <a:buNone/>
               <a:defRPr sz="1275">
                 <a:solidFill>
                   <a:srgbClr val="FFFFFF"/>

</xml_diff>